<commit_message>
fix(ppt): enhance typography, increase font sizes, and optimize shape alignments across all slides
</commit_message>
<xml_diff>
--- a/PPT/SIH2026-IDEA-Presentation-Xtream-09.pptx
+++ b/PPT/SIH2026-IDEA-Presentation-Xtream-09.pptx
@@ -5727,6 +5727,16 @@
           <a:bodyPr/>
           <a:lstStyle/>
           <a:p>
+            <a:pPr algn="l">
+              <a:defRPr sz="2600" b="1">
+                <a:solidFill>
+                  <a:srgbClr val="105532"/>
+                </a:solidFill>
+              </a:defRPr>
+            </a:pPr>
+            <a:r>
+              <a:t>SMART INDIA HACKATHON 2026</a:t>
+            </a:r>
             <a:endParaRPr lang="en-US" b="1" dirty="0">
               <a:solidFill>
                 <a:schemeClr val="tx1"/>
@@ -5735,25 +5745,6 @@
               <a:cs typeface="Times New Roman" panose="02020603050405020304" pitchFamily="18" charset="0"/>
             </a:endParaRPr>
           </a:p>
-          <a:p>
-            <a:r>
-              <a:rPr lang="en-US" b="1" dirty="0">
-                <a:solidFill>
-                  <a:schemeClr val="tx1"/>
-                </a:solidFill>
-                <a:latin typeface="Times New Roman" panose="02020603050405020304" pitchFamily="18" charset="0"/>
-                <a:cs typeface="Times New Roman" panose="02020603050405020304" pitchFamily="18" charset="0"/>
-              </a:rPr>
-              <a:t>TITLE PAGE</a:t>
-            </a:r>
-            <a:endParaRPr lang="en-IN" b="1" dirty="0">
-              <a:solidFill>
-                <a:schemeClr val="tx1"/>
-              </a:solidFill>
-              <a:latin typeface="Times New Roman" panose="02020603050405020304" pitchFamily="18" charset="0"/>
-              <a:cs typeface="Times New Roman" panose="02020603050405020304" pitchFamily="18" charset="0"/>
-            </a:endParaRPr>
-          </a:p>
         </p:txBody>
       </p:sp>
       <p:sp>
@@ -5776,24 +5767,6 @@
           <a:bodyPr/>
           <a:lstStyle/>
           <a:p>
-            <a:r>
-              <a:rPr lang="en-US" sz="4000" b="1" dirty="0">
-                <a:solidFill>
-                  <a:schemeClr val="tx2"/>
-                </a:solidFill>
-                <a:latin typeface="Garamond" panose="02020404030301010803" pitchFamily="18" charset="0"/>
-              </a:rPr>
-              <a:t>SMART INDIA HACKATHON </a:t>
-            </a:r>
-            <a:r>
-              <a:rPr lang="en-US" sz="4000" b="1" dirty="0" smtClean="0">
-                <a:solidFill>
-                  <a:schemeClr val="tx2"/>
-                </a:solidFill>
-                <a:latin typeface="Garamond" panose="02020404030301010803" pitchFamily="18" charset="0"/>
-              </a:rPr>
-              <a:t>2026</a:t>
-            </a:r>
             <a:endParaRPr lang="en-IN" sz="4000" b="1" dirty="0">
               <a:solidFill>
                 <a:schemeClr val="tx2"/>
@@ -5811,8 +5784,8 @@
         </p:nvSpPr>
         <p:spPr>
           <a:xfrm>
-            <a:off x="331286" y="2076450"/>
-            <a:ext cx="5924550" cy="4703019"/>
+            <a:off x="612648" y="1691640"/>
+            <a:ext cx="6217920" cy="4663440"/>
           </a:xfrm>
           <a:prstGeom prst="rect">
             <a:avLst/>
@@ -5827,150 +5800,135 @@
           <a:p>
             <a:pPr>
               <a:spcAft>
-                <a:spcPts val="1200"/>
+                <a:spcPts val="1400"/>
               </a:spcAft>
-              <a:defRPr sz="2000" b="1">
+            </a:pPr>
+            <a:r>
+              <a:rPr b="1" sz="1600">
+                <a:solidFill>
+                  <a:srgbClr val="0F172A"/>
+                </a:solidFill>
+              </a:rPr>
+              <a:t>Problem Statement ID:</a:t>
+            </a:r>
+            <a:r>
+              <a:rPr b="1" sz="1700">
                 <a:solidFill>
                   <a:srgbClr val="105532"/>
                 </a:solidFill>
-              </a:defRPr>
-            </a:pPr>
-            <a:r>
-              <a:t>SMART INDIA HACKATHON 2026</a:t>
+              </a:rPr>
+              <a:t> SIH26082</a:t>
             </a:r>
             <a:endParaRPr lang="en-US" dirty="0"/>
           </a:p>
           <a:p>
             <a:pPr>
               <a:spcAft>
-                <a:spcPts val="800"/>
+                <a:spcPts val="1400"/>
               </a:spcAft>
             </a:pPr>
             <a:r>
-              <a:rPr b="1" sz="1500">
+              <a:rPr b="1" sz="1600">
+                <a:solidFill>
+                  <a:srgbClr val="0F172A"/>
+                </a:solidFill>
+              </a:rPr>
+              <a:t>Problem Statement Title:</a:t>
+            </a:r>
+            <a:r>
+              <a:rPr b="1" sz="1700">
                 <a:solidFill>
                   <a:srgbClr val="1E293B"/>
                 </a:solidFill>
               </a:rPr>
-              <a:t>Problem Statement ID:</a:t>
-            </a:r>
-            <a:r>
-              <a:rPr b="1" sz="1500">
-                <a:solidFill>
-                  <a:srgbClr val="0F172A"/>
-                </a:solidFill>
-              </a:rPr>
-              <a:t> SIH26082</a:t>
+              <a:t> Air Pollution - Weather Coupled Forecast</a:t>
             </a:r>
           </a:p>
           <a:p>
             <a:pPr>
               <a:spcAft>
-                <a:spcPts val="800"/>
+                <a:spcPts val="1400"/>
               </a:spcAft>
             </a:pPr>
             <a:r>
-              <a:rPr b="1" sz="1500">
-                <a:solidFill>
-                  <a:srgbClr val="1E293B"/>
-                </a:solidFill>
-              </a:rPr>
-              <a:t>Problem Statement Title:</a:t>
-            </a:r>
-            <a:r>
-              <a:rPr b="0" sz="1500">
+              <a:rPr b="1" sz="1600">
                 <a:solidFill>
                   <a:srgbClr val="0F172A"/>
                 </a:solidFill>
               </a:rPr>
-              <a:t> Air Pollution - Weather Coupled Forecast</a:t>
+              <a:t>Theme:</a:t>
+            </a:r>
+            <a:r>
+              <a:rPr b="1" sz="1700">
+                <a:solidFill>
+                  <a:srgbClr val="105532"/>
+                </a:solidFill>
+              </a:rPr>
+              <a:t> Clean &amp; Green Technology</a:t>
             </a:r>
           </a:p>
           <a:p>
             <a:pPr>
               <a:spcAft>
-                <a:spcPts val="800"/>
+                <a:spcPts val="1400"/>
               </a:spcAft>
             </a:pPr>
             <a:r>
-              <a:rPr b="1" sz="1500">
+              <a:rPr b="1" sz="1600">
+                <a:solidFill>
+                  <a:srgbClr val="0F172A"/>
+                </a:solidFill>
+              </a:rPr>
+              <a:t>PS Category:</a:t>
+            </a:r>
+            <a:r>
+              <a:rPr b="1" sz="1700">
                 <a:solidFill>
                   <a:srgbClr val="1E293B"/>
                 </a:solidFill>
               </a:rPr>
-              <a:t>Theme:</a:t>
-            </a:r>
-            <a:r>
-              <a:rPr b="1" sz="1500">
-                <a:solidFill>
-                  <a:srgbClr val="105532"/>
-                </a:solidFill>
-              </a:rPr>
-              <a:t> Clean &amp; Green Technology</a:t>
+              <a:t> Software</a:t>
             </a:r>
           </a:p>
           <a:p>
             <a:pPr>
               <a:spcAft>
-                <a:spcPts val="800"/>
+                <a:spcPts val="1400"/>
               </a:spcAft>
             </a:pPr>
             <a:r>
-              <a:rPr b="1" sz="1500">
+              <a:rPr b="1" sz="1600">
+                <a:solidFill>
+                  <a:srgbClr val="0F172A"/>
+                </a:solidFill>
+              </a:rPr>
+              <a:t>Team ID:</a:t>
+            </a:r>
+            <a:r>
+              <a:rPr b="1" sz="1700">
                 <a:solidFill>
                   <a:srgbClr val="1E293B"/>
                 </a:solidFill>
               </a:rPr>
-              <a:t>PS Category:</a:t>
-            </a:r>
-            <a:r>
-              <a:rPr b="0" sz="1500">
-                <a:solidFill>
-                  <a:srgbClr val="0F172A"/>
-                </a:solidFill>
-              </a:rPr>
-              <a:t> Software</a:t>
+              <a:t> 09</a:t>
             </a:r>
           </a:p>
           <a:p>
             <a:pPr>
               <a:spcAft>
-                <a:spcPts val="800"/>
+                <a:spcPts val="1400"/>
               </a:spcAft>
             </a:pPr>
             <a:r>
-              <a:rPr b="1" sz="1500">
-                <a:solidFill>
-                  <a:srgbClr val="1E293B"/>
-                </a:solidFill>
-              </a:rPr>
-              <a:t>Team ID:</a:t>
-            </a:r>
-            <a:r>
-              <a:rPr b="0" sz="1500">
+              <a:rPr b="1" sz="1600">
                 <a:solidFill>
                   <a:srgbClr val="0F172A"/>
                 </a:solidFill>
               </a:rPr>
-              <a:t> 09</a:t>
-            </a:r>
-          </a:p>
-          <a:p>
-            <a:pPr>
-              <a:spcAft>
-                <a:spcPts val="800"/>
-              </a:spcAft>
-            </a:pPr>
-            <a:r>
-              <a:rPr b="1" sz="1500">
-                <a:solidFill>
-                  <a:srgbClr val="1E293B"/>
-                </a:solidFill>
-              </a:rPr>
               <a:t>Team Name:</a:t>
             </a:r>
             <a:r>
-              <a:rPr b="1" sz="1500">
+              <a:rPr b="1" sz="1700">
                 <a:solidFill>
                   <a:srgbClr val="105532"/>
                 </a:solidFill>
@@ -6105,16 +6063,16 @@
         </p:nvSpPr>
         <p:spPr>
           <a:xfrm>
-            <a:off x="182998" y="0"/>
-            <a:ext cx="10972800" cy="1143000"/>
+            <a:off x="2926080" y="201168"/>
+            <a:ext cx="6766560" cy="731520"/>
           </a:xfrm>
         </p:spPr>
         <p:txBody>
-          <a:bodyPr/>
+          <a:bodyPr wrap="square"/>
           <a:lstStyle/>
           <a:p>
-            <a:pPr eaLnBrk="1" hangingPunct="1">
-              <a:defRPr sz="2000" b="1">
+            <a:pPr eaLnBrk="1" hangingPunct="1" algn="l">
+              <a:defRPr sz="1700" b="1">
                 <a:solidFill>
                   <a:srgbClr val="105532"/>
                 </a:solidFill>
@@ -6136,8 +6094,8 @@
         </p:nvSpPr>
         <p:spPr bwMode="auto">
           <a:xfrm>
-            <a:off x="-1" y="2064921"/>
-            <a:ext cx="12191999" cy="2492990"/>
+            <a:off x="612648" y="1143000"/>
+            <a:ext cx="10881360" cy="4983480"/>
           </a:xfrm>
           <a:prstGeom prst="rect">
             <a:avLst/>
@@ -6158,16 +6116,16 @@
           <a:p>
             <a:pPr marL="342900" indent="-342900">
               <a:spcBef>
-                <a:spcPts val="600"/>
+                <a:spcPts val="0"/>
               </a:spcBef>
               <a:spcAft>
-                <a:spcPts val="200"/>
+                <a:spcPts val="300"/>
               </a:spcAft>
               <a:buFont typeface="Wingdings" panose="05000000000000000000" pitchFamily="2" charset="2"/>
               <a:buChar char="v"/>
             </a:pPr>
             <a:r>
-              <a:rPr b="1" sz="1300">
+              <a:rPr b="1" sz="1550">
                 <a:solidFill>
                   <a:srgbClr val="105532"/>
                 </a:solidFill>
@@ -6183,159 +6141,177 @@
             </a:endParaRPr>
           </a:p>
           <a:p>
-            <a:pPr lvl="1">
+            <a:pPr>
               <a:spcAft>
-                <a:spcPts val="200"/>
+                <a:spcPts val="400"/>
               </a:spcAft>
             </a:pPr>
             <a:r>
-              <a:rPr sz="1100">
+              <a:rPr b="1" sz="1300">
                 <a:solidFill>
                   <a:srgbClr val="0F172A"/>
                 </a:solidFill>
               </a:rPr>
-              <a:t>- A physics-informed atmospheric intelligence system that couples real-time air quality metrics with meteorological dynamics to generate high-resolution, short-term coupled forecasts.</a:t>
-            </a:r>
-          </a:p>
-          <a:p>
-            <a:pPr lvl="1">
+              <a:t>• Physics-Informed Atmospheric Coupling:</a:t>
+            </a:r>
+            <a:r>
+              <a:rPr b="0" sz="1300">
+                <a:solidFill>
+                  <a:srgbClr val="1E293B"/>
+                </a:solidFill>
+              </a:rPr>
+              <a:t> Integrates real-time chemical air quality metrics with meteorological dynamics to generate high-resolution, short-term coupled forecasts.</a:t>
+            </a:r>
+          </a:p>
+          <a:p>
+            <a:pPr>
               <a:spcAft>
-                <a:spcPts val="200"/>
+                <a:spcPts val="400"/>
               </a:spcAft>
             </a:pPr>
             <a:r>
-              <a:rPr sz="1100">
+              <a:rPr b="1" sz="1300">
                 <a:solidFill>
                   <a:srgbClr val="0F172A"/>
                 </a:solidFill>
               </a:rPr>
-              <a:t>- Dynamically models how wind shear, boundary layer thermal inversions, rain washout, and barometric pressure alter ground-level pollution concentrations hour by hour.</a:t>
+              <a:t>• Dynamic Multi-Factor Modeling:</a:t>
+            </a:r>
+            <a:r>
+              <a:rPr b="0" sz="1300">
+                <a:solidFill>
+                  <a:srgbClr val="1E293B"/>
+                </a:solidFill>
+              </a:rPr>
+              <a:t> Accurately simulates how wind shear, boundary layer thermal inversions, rain scavenging, and barometric pressure modify ground-level pollution concentrations.</a:t>
             </a:r>
           </a:p>
           <a:p>
             <a:pPr>
               <a:spcBef>
-                <a:spcPts val="600"/>
+                <a:spcPts val="800"/>
               </a:spcBef>
               <a:spcAft>
-                <a:spcPts val="200"/>
+                <a:spcPts val="300"/>
               </a:spcAft>
             </a:pPr>
             <a:r>
+              <a:rPr b="1" sz="1550">
+                <a:solidFill>
+                  <a:srgbClr val="105532"/>
+                </a:solidFill>
+              </a:rPr>
+              <a:t>2. How It Addresses the Problem:</a:t>
+            </a:r>
+          </a:p>
+          <a:p>
+            <a:pPr>
+              <a:spcAft>
+                <a:spcPts val="400"/>
+              </a:spcAft>
+            </a:pPr>
+            <a:r>
               <a:rPr b="1" sz="1300">
                 <a:solidFill>
-                  <a:srgbClr val="105532"/>
-                </a:solidFill>
-              </a:rPr>
-              <a:t>2. How It Addresses the Problem:</a:t>
-            </a:r>
-          </a:p>
-          <a:p>
-            <a:pPr lvl="1">
+                  <a:srgbClr val="0F172A"/>
+                </a:solidFill>
+              </a:rPr>
+              <a:t>• Bridges Static Observation Gaps:</a:t>
+            </a:r>
+            <a:r>
+              <a:rPr b="0" sz="1300">
+                <a:solidFill>
+                  <a:srgbClr val="1E293B"/>
+                </a:solidFill>
+              </a:rPr>
+              <a:t> Replaces lagging ground sensor measurements with proactive microclimate-informed forecasts.</a:t>
+            </a:r>
+          </a:p>
+          <a:p>
+            <a:pPr>
               <a:spcAft>
-                <a:spcPts val="200"/>
+                <a:spcPts val="400"/>
               </a:spcAft>
             </a:pPr>
             <a:r>
-              <a:rPr sz="1100">
+              <a:rPr b="1" sz="1300">
                 <a:solidFill>
                   <a:srgbClr val="0F172A"/>
                 </a:solidFill>
               </a:rPr>
-              <a:t>- Bridges the gap between static chemical transport estimates and real-time microclimate variations.</a:t>
-            </a:r>
-          </a:p>
-          <a:p>
-            <a:pPr lvl="1">
-              <a:spcAft>
-                <a:spcPts val="200"/>
-              </a:spcAft>
-            </a:pPr>
-            <a:r>
-              <a:rPr sz="1100">
-                <a:solidFill>
-                  <a:srgbClr val="0F172A"/>
-                </a:solidFill>
-              </a:rPr>
-              <a:t>- Predicts critical pollution accumulation events (e.g., nocturnal cold pool inversions) and dispersion windows (e.g., afternoon wind/rain) before they occur.</a:t>
-            </a:r>
-          </a:p>
-          <a:p>
-            <a:pPr lvl="1">
-              <a:spcAft>
-                <a:spcPts val="200"/>
-              </a:spcAft>
-            </a:pPr>
-            <a:r>
-              <a:rPr sz="1100">
-                <a:solidFill>
-                  <a:srgbClr val="0F172A"/>
-                </a:solidFill>
-              </a:rPr>
-              <a:t>- Provides citizens and urban planners with actionable, forward-looking health advisories.</a:t>
+              <a:t>• Anticipates Smog Trapping &amp; Clearing:</a:t>
+            </a:r>
+            <a:r>
+              <a:rPr b="0" sz="1300">
+                <a:solidFill>
+                  <a:srgbClr val="1E293B"/>
+                </a:solidFill>
+              </a:rPr>
+              <a:t> Detects nocturnal inversion accumulation and daytime convective dispersion windows before they occur.</a:t>
             </a:r>
           </a:p>
           <a:p>
             <a:pPr>
               <a:spcBef>
-                <a:spcPts val="600"/>
+                <a:spcPts val="800"/>
               </a:spcBef>
               <a:spcAft>
-                <a:spcPts val="200"/>
+                <a:spcPts val="300"/>
               </a:spcAft>
             </a:pPr>
             <a:r>
+              <a:rPr b="1" sz="1550">
+                <a:solidFill>
+                  <a:srgbClr val="105532"/>
+                </a:solidFill>
+              </a:rPr>
+              <a:t>3. Innovation &amp; Uniqueness:</a:t>
+            </a:r>
+          </a:p>
+          <a:p>
+            <a:pPr>
+              <a:spcAft>
+                <a:spcPts val="400"/>
+              </a:spcAft>
+            </a:pPr>
+            <a:r>
               <a:rPr b="1" sz="1300">
                 <a:solidFill>
-                  <a:srgbClr val="105532"/>
-                </a:solidFill>
-              </a:rPr>
-              <a:t>3. Innovation &amp; Uniqueness:</a:t>
-            </a:r>
-          </a:p>
-          <a:p>
-            <a:pPr lvl="1">
+                  <a:srgbClr val="0F172A"/>
+                </a:solidFill>
+              </a:rPr>
+              <a:t>• Transparent Explainability:</a:t>
+            </a:r>
+            <a:r>
+              <a:rPr b="0" sz="1300">
+                <a:solidFill>
+                  <a:srgbClr val="1E293B"/>
+                </a:solidFill>
+              </a:rPr>
+              <a:t> Provides an exact mathematical delta breakdown (+/- AQI) attributing numerical points to wind, rain, and inversion.</a:t>
+            </a:r>
+          </a:p>
+          <a:p>
+            <a:pPr>
               <a:spcAft>
-                <a:spcPts val="200"/>
+                <a:spcPts val="400"/>
               </a:spcAft>
             </a:pPr>
             <a:r>
-              <a:rPr sz="1100">
+              <a:rPr b="1" sz="1300">
                 <a:solidFill>
                   <a:srgbClr val="0F172A"/>
                 </a:solidFill>
               </a:rPr>
-              <a:t>- Deterministic Explainable Heuristics: Transparent numerical delta breakdown (+/- AQI) attributing exact impact to wind, rain, and inversion.</a:t>
-            </a:r>
-          </a:p>
-          <a:p>
-            <a:pPr lvl="1">
-              <a:spcAft>
-                <a:spcPts val="200"/>
-              </a:spcAft>
-            </a:pPr>
-            <a:r>
-              <a:rPr sz="1100">
-                <a:solidFill>
-                  <a:srgbClr val="0F172A"/>
-                </a:solidFill>
-              </a:rPr>
-              <a:t>- Zero-Cost Keyless Architecture: Operates on global Open-Meteo open APIs with 100% uptime fallback.</a:t>
-            </a:r>
-          </a:p>
-          <a:p>
-            <a:pPr lvl="1">
-              <a:spcAft>
-                <a:spcPts val="200"/>
-              </a:spcAft>
-            </a:pPr>
-            <a:r>
-              <a:rPr sz="1100">
-                <a:solidFill>
-                  <a:srgbClr val="0F172A"/>
-                </a:solidFill>
-              </a:rPr>
-              <a:t>- Actionable Intelligence: Recommends optimal outdoor workout windows and smart window ventilation timing.</a:t>
+              <a:t>• Zero-Cost Keyless Architecture:</a:t>
+            </a:r>
+            <a:r>
+              <a:rPr b="0" sz="1300">
+                <a:solidFill>
+                  <a:srgbClr val="1E293B"/>
+                </a:solidFill>
+              </a:rPr>
+              <a:t> Operates entirely on public Open-Meteo APIs with a deterministic physical fallback model for 100% uptime.</a:t>
             </a:r>
           </a:p>
         </p:txBody>
@@ -6428,8 +6404,8 @@
         </p:nvSpPr>
         <p:spPr>
           <a:xfrm>
-            <a:off x="329773" y="252246"/>
-            <a:ext cx="1251857" cy="807334"/>
+            <a:off x="612648" y="256032"/>
+            <a:ext cx="2148840" cy="594360"/>
           </a:xfrm>
           <a:prstGeom prst="ellipse">
             <a:avLst/>
@@ -6450,11 +6426,11 @@
           </a:fontRef>
         </p:style>
         <p:txBody>
-          <a:bodyPr rtlCol="0" anchor="ctr"/>
+          <a:bodyPr rtlCol="0" anchor="ctr" wrap="square"/>
           <a:lstStyle/>
           <a:p>
             <a:pPr algn="ctr">
-              <a:defRPr sz="1000" b="1">
+              <a:defRPr sz="1150" b="1">
                 <a:solidFill>
                   <a:srgbClr val="FFFFFF"/>
                 </a:solidFill>
@@ -6596,13 +6572,18 @@
             <p:ph type="title"/>
           </p:nvPr>
         </p:nvSpPr>
-        <p:spPr/>
-        <p:txBody>
-          <a:bodyPr/>
+        <p:spPr>
+          <a:xfrm>
+            <a:off x="2926080" y="201168"/>
+            <a:ext cx="6766560" cy="731520"/>
+          </a:xfrm>
+        </p:spPr>
+        <p:txBody>
+          <a:bodyPr wrap="square"/>
           <a:lstStyle/>
           <a:p>
-            <a:pPr eaLnBrk="1" hangingPunct="1">
-              <a:defRPr sz="2000" b="1">
+            <a:pPr eaLnBrk="1" hangingPunct="1" algn="l">
+              <a:defRPr sz="1700" b="1">
                 <a:solidFill>
                   <a:srgbClr val="105532"/>
                 </a:solidFill>
@@ -6624,8 +6605,8 @@
         </p:nvSpPr>
         <p:spPr bwMode="auto">
           <a:xfrm>
-            <a:off x="609600" y="2533653"/>
-            <a:ext cx="9385300" cy="1815882"/>
+            <a:off x="612648" y="1143000"/>
+            <a:ext cx="10881360" cy="4983480"/>
           </a:xfrm>
           <a:prstGeom prst="rect">
             <a:avLst/>
@@ -6646,159 +6627,177 @@
           <a:p>
             <a:pPr marL="342900" indent="-342900" algn="just">
               <a:spcBef>
-                <a:spcPts val="600"/>
+                <a:spcPts val="0"/>
               </a:spcBef>
               <a:spcAft>
-                <a:spcPts val="200"/>
+                <a:spcPts val="300"/>
               </a:spcAft>
               <a:buFont typeface="Arial" panose="020B0604020202020204" pitchFamily="34" charset="0"/>
               <a:buChar char="•"/>
             </a:pPr>
             <a:r>
+              <a:rPr b="1" sz="1550">
+                <a:solidFill>
+                  <a:srgbClr val="105532"/>
+                </a:solidFill>
+              </a:rPr>
+              <a:t>1. Technology Stack &amp; Frameworks:</a:t>
+            </a:r>
+          </a:p>
+          <a:p>
+            <a:pPr>
+              <a:spcAft>
+                <a:spcPts val="400"/>
+              </a:spcAft>
+            </a:pPr>
+            <a:r>
               <a:rPr b="1" sz="1300">
                 <a:solidFill>
-                  <a:srgbClr val="105532"/>
-                </a:solidFill>
-              </a:rPr>
-              <a:t>1. Technologies &amp; Architecture:</a:t>
-            </a:r>
-          </a:p>
-          <a:p>
-            <a:pPr lvl="1">
+                  <a:srgbClr val="0F172A"/>
+                </a:solidFill>
+              </a:rPr>
+              <a:t>• Core Architecture:</a:t>
+            </a:r>
+            <a:r>
+              <a:rPr b="0" sz="1300">
+                <a:solidFill>
+                  <a:srgbClr val="1E293B"/>
+                </a:solidFill>
+              </a:rPr>
+              <a:t> Next.js 16 (App Router, React 19) + TypeScript 5 (Strict Mode) for high-performance edge compute.</a:t>
+            </a:r>
+          </a:p>
+          <a:p>
+            <a:pPr>
               <a:spcAft>
-                <a:spcPts val="200"/>
+                <a:spcPts val="400"/>
               </a:spcAft>
             </a:pPr>
             <a:r>
-              <a:rPr sz="1100">
+              <a:rPr b="1" sz="1300">
                 <a:solidFill>
                   <a:srgbClr val="0F172A"/>
                 </a:solidFill>
               </a:rPr>
-              <a:t>- Frontend &amp; Backend: Next.js 16 (App Router, Turbopack, React 19) + TypeScript 5 (Strict Mode).</a:t>
-            </a:r>
-          </a:p>
-          <a:p>
-            <a:pPr lvl="1">
+              <a:t>• UI &amp; Visualization:</a:t>
+            </a:r>
+            <a:r>
+              <a:rPr b="0" sz="1300">
+                <a:solidFill>
+                  <a:srgbClr val="1E293B"/>
+                </a:solidFill>
+              </a:rPr>
+              <a:t> Tailwind CSS v4, enterprise design tokens (Light/Dark mode), and Recharts 3.10 multi-axis interactive composed charts.</a:t>
+            </a:r>
+          </a:p>
+          <a:p>
+            <a:pPr>
               <a:spcAft>
-                <a:spcPts val="200"/>
+                <a:spcPts val="400"/>
               </a:spcAft>
             </a:pPr>
             <a:r>
-              <a:rPr sz="1100">
+              <a:rPr b="1" sz="1300">
                 <a:solidFill>
                   <a:srgbClr val="0F172A"/>
                 </a:solidFill>
               </a:rPr>
-              <a:t>- Styling &amp; Design System: Tailwind CSS v4, enterprise tokens, default Light mode with Dark mode toggle.</a:t>
-            </a:r>
-          </a:p>
-          <a:p>
-            <a:pPr lvl="1">
-              <a:spcAft>
-                <a:spcPts val="200"/>
-              </a:spcAft>
-            </a:pPr>
-            <a:r>
-              <a:rPr sz="1100">
-                <a:solidFill>
-                  <a:srgbClr val="0F172A"/>
-                </a:solidFill>
-              </a:rPr>
-              <a:t>- Data Visualization: Recharts 3.10 multi-axis interactive composed charts (Coupled AQI, Weather, Pollutants).</a:t>
-            </a:r>
-          </a:p>
-          <a:p>
-            <a:pPr lvl="1">
-              <a:spcAft>
-                <a:spcPts val="200"/>
-              </a:spcAft>
-            </a:pPr>
-            <a:r>
-              <a:rPr sz="1100">
-                <a:solidFill>
-                  <a:srgbClr val="0F172A"/>
-                </a:solidFill>
-              </a:rPr>
-              <a:t>- Data Layer: Open-Meteo APIs (Global Weather, Air Quality, Geocoding) + Synthetic Fallback Engine.</a:t>
+              <a:t>• Data Integration:</a:t>
+            </a:r>
+            <a:r>
+              <a:rPr b="0" sz="1300">
+                <a:solidFill>
+                  <a:srgbClr val="1E293B"/>
+                </a:solidFill>
+              </a:rPr>
+              <a:t> Open-Meteo Forecast, Air Quality, and Geocoding APIs coupled with a built-in synthetic atmospheric model.</a:t>
             </a:r>
           </a:p>
           <a:p>
             <a:pPr>
               <a:spcBef>
-                <a:spcPts val="600"/>
+                <a:spcPts val="800"/>
               </a:spcBef>
               <a:spcAft>
-                <a:spcPts val="200"/>
+                <a:spcPts val="300"/>
               </a:spcAft>
             </a:pPr>
             <a:r>
+              <a:rPr b="1" sz="1550">
+                <a:solidFill>
+                  <a:srgbClr val="105532"/>
+                </a:solidFill>
+              </a:rPr>
+              <a:t>2. Methodology &amp; Coupling Pipeline:</a:t>
+            </a:r>
+          </a:p>
+          <a:p>
+            <a:pPr>
+              <a:spcAft>
+                <a:spcPts val="400"/>
+              </a:spcAft>
+            </a:pPr>
+            <a:r>
               <a:rPr b="1" sz="1300">
                 <a:solidFill>
-                  <a:srgbClr val="105532"/>
-                </a:solidFill>
-              </a:rPr>
-              <a:t>2. Methodology &amp; Mathematical Coupling Pipeline:</a:t>
-            </a:r>
-          </a:p>
-          <a:p>
-            <a:pPr lvl="1">
+                  <a:srgbClr val="0F172A"/>
+                </a:solidFill>
+              </a:rPr>
+              <a:t>• Atmospheric Ingestion:</a:t>
+            </a:r>
+            <a:r>
+              <a:rPr b="0" sz="1300">
+                <a:solidFill>
+                  <a:srgbClr val="1E293B"/>
+                </a:solidFill>
+              </a:rPr>
+              <a:t> Streams 48-hour hourly weather (wind, gusts, temp, humidity, pressure, rain) &amp; pollutants (PM2.5, PM10, O3, NO2, SO2, CO).</a:t>
+            </a:r>
+          </a:p>
+          <a:p>
+            <a:pPr>
               <a:spcAft>
-                <a:spcPts val="200"/>
+                <a:spcPts val="400"/>
               </a:spcAft>
             </a:pPr>
             <a:r>
-              <a:rPr sz="1100">
+              <a:rPr b="1" sz="1300">
                 <a:solidFill>
                   <a:srgbClr val="0F172A"/>
                 </a:solidFill>
               </a:rPr>
-              <a:t>- Ingestion Layer: Queries 48-hour hourly weather (wind, temp, humidity, pressure, rain) &amp; air quality (PM2.5, PM10, O3, NO2, SO2, CO).</a:t>
-            </a:r>
-          </a:p>
-          <a:p>
-            <a:pPr lvl="1">
+              <a:t>• Coupling Heuristic Engine:</a:t>
+            </a:r>
+            <a:r>
+              <a:rPr b="0" sz="1300">
+                <a:solidFill>
+                  <a:srgbClr val="1E293B"/>
+                </a:solidFill>
+              </a:rPr>
+              <a:t> Calculates: Coupled AQI = Raw AQI + Delta_wind + Delta_stability + Delta_precip + Delta_photochem + Delta_pressure.</a:t>
+            </a:r>
+          </a:p>
+          <a:p>
+            <a:pPr>
               <a:spcAft>
-                <a:spcPts val="200"/>
+                <a:spcPts val="400"/>
               </a:spcAft>
             </a:pPr>
             <a:r>
-              <a:rPr sz="1100">
+              <a:rPr b="1" sz="1300">
                 <a:solidFill>
                   <a:srgbClr val="0F172A"/>
                 </a:solidFill>
               </a:rPr>
-              <a:t>- Atmospheric Coupling Engine: Computes hourly delta: Coupled AQI = Raw AQI + Delta_wind + Delta_stability + Delta_precip + Delta_photochem + Delta_pressure.</a:t>
-            </a:r>
-          </a:p>
-          <a:p>
-            <a:pPr lvl="1">
-              <a:spcAft>
-                <a:spcPts val="200"/>
-              </a:spcAft>
-            </a:pPr>
-            <a:r>
-              <a:rPr sz="1100">
-                <a:solidFill>
-                  <a:srgbClr val="0F172A"/>
-                </a:solidFill>
-              </a:rPr>
-              <a:t>- Analytics &amp; Visual Deck: Displays Hero AQI gauge, EPA severity bands, 24h timeline reel, and factor diagnostics.</a:t>
-            </a:r>
-          </a:p>
-          <a:p>
-            <a:pPr lvl="1">
-              <a:spcAft>
-                <a:spcPts val="200"/>
-              </a:spcAft>
-            </a:pPr>
-            <a:r>
-              <a:rPr sz="1100">
-                <a:solidFill>
-                  <a:srgbClr val="0F172A"/>
-                </a:solidFill>
-              </a:rPr>
-              <a:t>- Decision Support: Synthesizes plain-language AI insights, best outdoor exercise windows, and vulnerable group warnings.</a:t>
+              <a:t>• Actionable Analytics Deck:</a:t>
+            </a:r>
+            <a:r>
+              <a:rPr b="0" sz="1300">
+                <a:solidFill>
+                  <a:srgbClr val="1E293B"/>
+                </a:solidFill>
+              </a:rPr>
+              <a:t> Real-time Hero AQI card, 24h timeline reel, factor diagnostics, and optimal outdoor activity recommendations.</a:t>
             </a:r>
           </a:p>
         </p:txBody>
@@ -6891,8 +6890,8 @@
         </p:nvSpPr>
         <p:spPr>
           <a:xfrm>
-            <a:off x="329773" y="252246"/>
-            <a:ext cx="1251857" cy="807334"/>
+            <a:off x="612648" y="256032"/>
+            <a:ext cx="2148840" cy="594360"/>
           </a:xfrm>
           <a:prstGeom prst="ellipse">
             <a:avLst/>
@@ -6913,11 +6912,11 @@
           </a:fontRef>
         </p:style>
         <p:txBody>
-          <a:bodyPr rtlCol="0" anchor="ctr"/>
+          <a:bodyPr rtlCol="0" anchor="ctr" wrap="square"/>
           <a:lstStyle/>
           <a:p>
             <a:pPr algn="ctr">
-              <a:defRPr sz="1000" b="1">
+              <a:defRPr sz="1150" b="1">
                 <a:solidFill>
                   <a:srgbClr val="FFFFFF"/>
                 </a:solidFill>
@@ -7074,13 +7073,18 @@
             <p:ph type="title"/>
           </p:nvPr>
         </p:nvSpPr>
-        <p:spPr/>
-        <p:txBody>
-          <a:bodyPr/>
+        <p:spPr>
+          <a:xfrm>
+            <a:off x="2926080" y="201168"/>
+            <a:ext cx="6766560" cy="731520"/>
+          </a:xfrm>
+        </p:spPr>
+        <p:txBody>
+          <a:bodyPr wrap="square"/>
           <a:lstStyle/>
           <a:p>
-            <a:pPr eaLnBrk="1" hangingPunct="1">
-              <a:defRPr sz="2000" b="1">
+            <a:pPr eaLnBrk="1" hangingPunct="1" algn="l">
+              <a:defRPr sz="1700" b="1">
                 <a:solidFill>
                   <a:srgbClr val="105532"/>
                 </a:solidFill>
@@ -7102,8 +7106,8 @@
         </p:nvSpPr>
         <p:spPr bwMode="auto">
           <a:xfrm>
-            <a:off x="609600" y="2533653"/>
-            <a:ext cx="9385300" cy="1384995"/>
+            <a:off x="612648" y="1143000"/>
+            <a:ext cx="10881360" cy="4983480"/>
           </a:xfrm>
           <a:prstGeom prst="rect">
             <a:avLst/>
@@ -7127,10 +7131,10 @@
                 <a:spcPct val="100000"/>
               </a:lnSpc>
               <a:spcBef>
-                <a:spcPts val="600"/>
+                <a:spcPts val="0"/>
               </a:spcBef>
               <a:spcAft>
-                <a:spcPts val="200"/>
+                <a:spcPts val="300"/>
               </a:spcAft>
               <a:buClrTx/>
               <a:buSzTx/>
@@ -7140,12 +7144,12 @@
               <a:defRPr/>
             </a:pPr>
             <a:r>
-              <a:rPr b="1" sz="1300">
+              <a:rPr b="1" sz="1550">
                 <a:solidFill>
                   <a:srgbClr val="105532"/>
                 </a:solidFill>
               </a:rPr>
-              <a:t>1. Feasibility Analysis:</a:t>
+              <a:t>1. Feasibility &amp; Operational Viability:</a:t>
             </a:r>
             <a:endParaRPr kumimoji="0" lang="en-US" sz="2800" b="0" i="0" u="none" strike="noStrike" kern="1200" cap="none" spc="0" normalizeH="0" baseline="0" noProof="0" dirty="0">
               <a:ln>
@@ -7163,144 +7167,200 @@
             </a:endParaRPr>
           </a:p>
           <a:p>
-            <a:pPr lvl="1">
+            <a:pPr>
               <a:spcAft>
-                <a:spcPts val="200"/>
+                <a:spcPts val="400"/>
               </a:spcAft>
             </a:pPr>
             <a:r>
-              <a:rPr sz="1100">
+              <a:rPr b="1" sz="1300">
                 <a:solidFill>
                   <a:srgbClr val="0F172A"/>
                 </a:solidFill>
               </a:rPr>
-              <a:t>- Zero Cost / High Availability: Utilizes free, open meteorological APIs without paid key dependencies or quota bottlenecks.</a:t>
-            </a:r>
-          </a:p>
-          <a:p>
-            <a:pPr lvl="1">
+              <a:t>• Zero API Overhead &amp; High Availability:</a:t>
+            </a:r>
+            <a:r>
+              <a:rPr b="0" sz="1300">
+                <a:solidFill>
+                  <a:srgbClr val="1E293B"/>
+                </a:solidFill>
+              </a:rPr>
+              <a:t> Free, keyless public infrastructure eliminates subscription costs and quota restrictions.</a:t>
+            </a:r>
+          </a:p>
+          <a:p>
+            <a:pPr>
               <a:spcAft>
-                <a:spcPts val="200"/>
+                <a:spcPts val="400"/>
               </a:spcAft>
             </a:pPr>
             <a:r>
-              <a:rPr sz="1100">
+              <a:rPr b="1" sz="1300">
                 <a:solidFill>
                   <a:srgbClr val="0F172A"/>
                 </a:solidFill>
               </a:rPr>
-              <a:t>- Edge-Ready Lightweight Compute: Mathematical coupling executes in &lt;50ms per query on standard edge runtimes.</a:t>
-            </a:r>
-          </a:p>
-          <a:p>
-            <a:pPr lvl="1">
+              <a:t>• Ultra-Low Latency Execution:</a:t>
+            </a:r>
+            <a:r>
+              <a:rPr b="0" sz="1300">
+                <a:solidFill>
+                  <a:srgbClr val="1E293B"/>
+                </a:solidFill>
+              </a:rPr>
+              <a:t> Mathematical coupling heuristics compute complete 48-hour trajectories in &lt;50ms per query.</a:t>
+            </a:r>
+          </a:p>
+          <a:p>
+            <a:pPr>
               <a:spcAft>
-                <a:spcPts val="200"/>
+                <a:spcPts val="400"/>
               </a:spcAft>
             </a:pPr>
             <a:r>
-              <a:rPr sz="1100">
+              <a:rPr b="1" sz="1300">
                 <a:solidFill>
                   <a:srgbClr val="0F172A"/>
                 </a:solidFill>
               </a:rPr>
-              <a:t>- Cross-Platform Accessibility: Ultra-responsive web application accessible across mobile, tablet, and desktop browsers with 1-click bookmarks.</a:t>
+              <a:t>• Cross-Platform Responsive Access:</a:t>
+            </a:r>
+            <a:r>
+              <a:rPr b="0" sz="1300">
+                <a:solidFill>
+                  <a:srgbClr val="1E293B"/>
+                </a:solidFill>
+              </a:rPr>
+              <a:t> Accessible on all devices with 1-click location bookmarking and GPS integration.</a:t>
             </a:r>
           </a:p>
           <a:p>
             <a:pPr>
               <a:spcBef>
-                <a:spcPts val="600"/>
+                <a:spcPts val="800"/>
               </a:spcBef>
               <a:spcAft>
-                <a:spcPts val="200"/>
+                <a:spcPts val="300"/>
               </a:spcAft>
             </a:pPr>
             <a:r>
+              <a:rPr b="1" sz="1550">
+                <a:solidFill>
+                  <a:srgbClr val="105532"/>
+                </a:solidFill>
+              </a:rPr>
+              <a:t>2. Potential Challenges &amp; Risks:</a:t>
+            </a:r>
+          </a:p>
+          <a:p>
+            <a:pPr>
+              <a:spcAft>
+                <a:spcPts val="400"/>
+              </a:spcAft>
+            </a:pPr>
+            <a:r>
               <a:rPr b="1" sz="1300">
                 <a:solidFill>
-                  <a:srgbClr val="105532"/>
-                </a:solidFill>
-              </a:rPr>
-              <a:t>2. Potential Challenges &amp; Risks:</a:t>
-            </a:r>
-          </a:p>
-          <a:p>
-            <a:pPr lvl="1">
+                  <a:srgbClr val="0F172A"/>
+                </a:solidFill>
+              </a:rPr>
+              <a:t>• External Network Latency / API Downtime:</a:t>
+            </a:r>
+            <a:r>
+              <a:rPr b="0" sz="1300">
+                <a:solidFill>
+                  <a:srgbClr val="1E293B"/>
+                </a:solidFill>
+              </a:rPr>
+              <a:t> Risk of third-party server slowdowns or connection timeouts.</a:t>
+            </a:r>
+          </a:p>
+          <a:p>
+            <a:pPr>
               <a:spcAft>
-                <a:spcPts val="200"/>
+                <a:spcPts val="400"/>
               </a:spcAft>
             </a:pPr>
             <a:r>
-              <a:rPr sz="1100">
+              <a:rPr b="1" sz="1300">
                 <a:solidFill>
                   <a:srgbClr val="0F172A"/>
                 </a:solidFill>
               </a:rPr>
-              <a:t>- External API Downtime / Latency: Transient network connection drops or third-party meteorological endpoint slowdowns.</a:t>
-            </a:r>
-          </a:p>
-          <a:p>
-            <a:pPr lvl="1">
-              <a:spcAft>
-                <a:spcPts val="200"/>
-              </a:spcAft>
-            </a:pPr>
-            <a:r>
-              <a:rPr sz="1100">
-                <a:solidFill>
-                  <a:srgbClr val="0F172A"/>
-                </a:solidFill>
-              </a:rPr>
-              <a:t>- Hyperlocal Variations: Urban street canyon effects and localized microclimates differing from macro weather stations.</a:t>
+              <a:t>• Microclimatic Urban Variations:</a:t>
+            </a:r>
+            <a:r>
+              <a:rPr b="0" sz="1300">
+                <a:solidFill>
+                  <a:srgbClr val="1E293B"/>
+                </a:solidFill>
+              </a:rPr>
+              <a:t> Localized urban street canyons differing from macro meteorological stations.</a:t>
             </a:r>
           </a:p>
           <a:p>
             <a:pPr>
               <a:spcBef>
-                <a:spcPts val="600"/>
+                <a:spcPts val="800"/>
               </a:spcBef>
               <a:spcAft>
-                <a:spcPts val="200"/>
+                <a:spcPts val="300"/>
               </a:spcAft>
             </a:pPr>
             <a:r>
+              <a:rPr b="1" sz="1550">
+                <a:solidFill>
+                  <a:srgbClr val="105532"/>
+                </a:solidFill>
+              </a:rPr>
+              <a:t>3. Risk Mitigation Strategies:</a:t>
+            </a:r>
+          </a:p>
+          <a:p>
+            <a:pPr>
+              <a:spcAft>
+                <a:spcPts val="400"/>
+              </a:spcAft>
+            </a:pPr>
+            <a:r>
               <a:rPr b="1" sz="1300">
                 <a:solidFill>
-                  <a:srgbClr val="105532"/>
-                </a:solidFill>
-              </a:rPr>
-              <a:t>3. Risk Mitigation Strategies:</a:t>
-            </a:r>
-          </a:p>
-          <a:p>
-            <a:pPr lvl="1">
+                  <a:srgbClr val="0F172A"/>
+                </a:solidFill>
+              </a:rPr>
+              <a:t>• Synthetic Atmospheric Fallback:</a:t>
+            </a:r>
+            <a:r>
+              <a:rPr b="0" sz="1300">
+                <a:solidFill>
+                  <a:srgbClr val="1E293B"/>
+                </a:solidFill>
+              </a:rPr>
+              <a:t> Automatically activates physical diurnal climate algorithms during network timeouts to guarantee zero-downtime.</a:t>
+            </a:r>
+          </a:p>
+          <a:p>
+            <a:pPr>
               <a:spcAft>
-                <a:spcPts val="200"/>
+                <a:spcPts val="400"/>
               </a:spcAft>
             </a:pPr>
             <a:r>
-              <a:rPr sz="1100">
+              <a:rPr b="1" sz="1300">
                 <a:solidFill>
                   <a:srgbClr val="0F172A"/>
                 </a:solidFill>
               </a:rPr>
-              <a:t>- Built-in Synthetic Atmospheric Fallback: Automatically activates physical diurnal climate models during API timeouts to ensure 100% uptime.</a:t>
-            </a:r>
-          </a:p>
-          <a:p>
-            <a:pPr lvl="1">
-              <a:spcAft>
-                <a:spcPts val="200"/>
-              </a:spcAft>
-            </a:pPr>
-            <a:r>
-              <a:rPr sz="1100">
-                <a:solidFill>
-                  <a:srgbClr val="0F172A"/>
-                </a:solidFill>
-              </a:rPr>
-              <a:t>- Offline Global Cities Index: 30+ major world cities pre-indexed for zero-latency local geocoding.</a:t>
+              <a:t>• Pre-Indexed Global City Database:</a:t>
+            </a:r>
+            <a:r>
+              <a:rPr b="0" sz="1300">
+                <a:solidFill>
+                  <a:srgbClr val="1E293B"/>
+                </a:solidFill>
+              </a:rPr>
+              <a:t> Instant local geocoding for 30+ major world hubs without network round-trips.</a:t>
             </a:r>
           </a:p>
         </p:txBody>
@@ -7476,8 +7536,8 @@
         </p:nvSpPr>
         <p:spPr>
           <a:xfrm>
-            <a:off x="329773" y="252246"/>
-            <a:ext cx="1251857" cy="807334"/>
+            <a:off x="612648" y="256032"/>
+            <a:ext cx="2148840" cy="594360"/>
           </a:xfrm>
           <a:prstGeom prst="ellipse">
             <a:avLst/>
@@ -7498,11 +7558,11 @@
           </a:fontRef>
         </p:style>
         <p:txBody>
-          <a:bodyPr rtlCol="0" anchor="ctr"/>
+          <a:bodyPr rtlCol="0" anchor="ctr" wrap="square"/>
           <a:lstStyle/>
           <a:p>
             <a:pPr algn="ctr">
-              <a:defRPr sz="1000" b="1">
+              <a:defRPr sz="1150" b="1">
                 <a:solidFill>
                   <a:srgbClr val="FFFFFF"/>
                 </a:solidFill>
@@ -7664,20 +7724,25 @@
             <p:ph type="title"/>
           </p:nvPr>
         </p:nvSpPr>
-        <p:spPr/>
-        <p:txBody>
-          <a:bodyPr/>
+        <p:spPr>
+          <a:xfrm>
+            <a:off x="2926080" y="201168"/>
+            <a:ext cx="6766560" cy="731520"/>
+          </a:xfrm>
+        </p:spPr>
+        <p:txBody>
+          <a:bodyPr wrap="square"/>
           <a:lstStyle/>
           <a:p>
-            <a:pPr eaLnBrk="1" hangingPunct="1">
-              <a:defRPr sz="2000" b="1">
+            <a:pPr eaLnBrk="1" hangingPunct="1" algn="l">
+              <a:defRPr sz="1700" b="1">
                 <a:solidFill>
                   <a:srgbClr val="105532"/>
                 </a:solidFill>
               </a:defRPr>
             </a:pPr>
             <a:r>
-              <a:t>IMPACT, BENEFITS &amp; SUSTAINABILITY</a:t>
+              <a:t>IMPACT, BENEFITS &amp; SUSTAINABILITY (CLEAN &amp; GREEN)</a:t>
             </a:r>
           </a:p>
         </p:txBody>
@@ -7692,8 +7757,8 @@
         </p:nvSpPr>
         <p:spPr bwMode="auto">
           <a:xfrm>
-            <a:off x="609600" y="2533653"/>
-            <a:ext cx="9385300" cy="1384995"/>
+            <a:off x="612648" y="1143000"/>
+            <a:ext cx="10881360" cy="4983480"/>
           </a:xfrm>
           <a:prstGeom prst="rect">
             <a:avLst/>
@@ -7717,10 +7782,10 @@
                 <a:spcPct val="100000"/>
               </a:lnSpc>
               <a:spcBef>
-                <a:spcPts val="600"/>
+                <a:spcPts val="0"/>
               </a:spcBef>
               <a:spcAft>
-                <a:spcPts val="200"/>
+                <a:spcPts val="300"/>
               </a:spcAft>
               <a:buClrTx/>
               <a:buSzTx/>
@@ -7730,168 +7795,168 @@
               <a:defRPr/>
             </a:pPr>
             <a:r>
+              <a:rPr b="1" sz="1550">
+                <a:solidFill>
+                  <a:srgbClr val="105532"/>
+                </a:solidFill>
+              </a:rPr>
+              <a:t>1. Target Audience Impact:</a:t>
+            </a:r>
+          </a:p>
+          <a:p>
+            <a:pPr>
+              <a:spcAft>
+                <a:spcPts val="400"/>
+              </a:spcAft>
+            </a:pPr>
+            <a:r>
               <a:rPr b="1" sz="1300">
                 <a:solidFill>
-                  <a:srgbClr val="105532"/>
-                </a:solidFill>
-              </a:rPr>
-              <a:t>1. Impact on Target Audience:</a:t>
-            </a:r>
-          </a:p>
-          <a:p>
-            <a:pPr lvl="1">
+                  <a:srgbClr val="0F172A"/>
+                </a:solidFill>
+              </a:rPr>
+              <a:t>• Citizens &amp; Commuters:</a:t>
+            </a:r>
+            <a:r>
+              <a:rPr b="0" sz="1300">
+                <a:solidFill>
+                  <a:srgbClr val="1E293B"/>
+                </a:solidFill>
+              </a:rPr>
+              <a:t> Real-time visibility into peak smog windows and cleanest outdoor travel/exercise hours.</a:t>
+            </a:r>
+          </a:p>
+          <a:p>
+            <a:pPr>
               <a:spcAft>
-                <a:spcPts val="200"/>
+                <a:spcPts val="400"/>
               </a:spcAft>
             </a:pPr>
             <a:r>
-              <a:rPr sz="1100">
+              <a:rPr b="1" sz="1300">
                 <a:solidFill>
                   <a:srgbClr val="0F172A"/>
                 </a:solidFill>
               </a:rPr>
-              <a:t>- Citizens &amp; Commuters: Real-time visibility into peak smog windows and optimal travel/exercise timings.</a:t>
-            </a:r>
-          </a:p>
-          <a:p>
-            <a:pPr lvl="1">
+              <a:t>• Sensitive Demographics:</a:t>
+            </a:r>
+            <a:r>
+              <a:rPr b="0" sz="1300">
+                <a:solidFill>
+                  <a:srgbClr val="1E293B"/>
+                </a:solidFill>
+              </a:rPr>
+              <a:t> Proactive alerts for asthmatics, children, and elderly citizens to prevent acute respiratory episodes.</a:t>
+            </a:r>
+          </a:p>
+          <a:p>
+            <a:pPr>
               <a:spcAft>
-                <a:spcPts val="200"/>
+                <a:spcPts val="400"/>
               </a:spcAft>
             </a:pPr>
             <a:r>
-              <a:rPr sz="1100">
+              <a:rPr b="1" sz="1300">
                 <a:solidFill>
                   <a:srgbClr val="0F172A"/>
                 </a:solidFill>
               </a:rPr>
-              <a:t>- Sensitive Demographics: Proactive alerts for asthmatics, children, and elderly citizens to prevent acute respiratory episodes.</a:t>
-            </a:r>
-          </a:p>
-          <a:p>
-            <a:pPr lvl="1">
-              <a:spcAft>
-                <a:spcPts val="200"/>
-              </a:spcAft>
-            </a:pPr>
-            <a:r>
-              <a:rPr sz="1100">
-                <a:solidFill>
-                  <a:srgbClr val="0F172A"/>
-                </a:solidFill>
-              </a:rPr>
-              <a:t>- Municipal Authorities: Data-backed triggers for anti-smog guns, street misting, and construction dust restrictions.</a:t>
+              <a:t>• Municipal Authorities:</a:t>
+            </a:r>
+            <a:r>
+              <a:rPr b="0" sz="1300">
+                <a:solidFill>
+                  <a:srgbClr val="1E293B"/>
+                </a:solidFill>
+              </a:rPr>
+              <a:t> Data-driven triggers for anti-smog guns, street misting, and construction dust regulations.</a:t>
             </a:r>
           </a:p>
           <a:p>
             <a:pPr>
               <a:spcBef>
-                <a:spcPts val="600"/>
+                <a:spcPts val="800"/>
               </a:spcBef>
               <a:spcAft>
-                <a:spcPts val="200"/>
+                <a:spcPts val="300"/>
               </a:spcAft>
             </a:pPr>
             <a:r>
+              <a:rPr b="1" sz="1550">
+                <a:solidFill>
+                  <a:srgbClr val="105532"/>
+                </a:solidFill>
+              </a:rPr>
+              <a:t>2. Multi-Dimensional Benefits:</a:t>
+            </a:r>
+          </a:p>
+          <a:p>
+            <a:pPr>
+              <a:spcAft>
+                <a:spcPts val="400"/>
+              </a:spcAft>
+            </a:pPr>
+            <a:r>
               <a:rPr b="1" sz="1300">
                 <a:solidFill>
-                  <a:srgbClr val="105532"/>
-                </a:solidFill>
-              </a:rPr>
-              <a:t>2. Multi-Dimensional Benefits:</a:t>
-            </a:r>
-          </a:p>
-          <a:p>
-            <a:pPr lvl="1">
+                  <a:srgbClr val="0F172A"/>
+                </a:solidFill>
+              </a:rPr>
+              <a:t>• Social &amp; Healthcare:</a:t>
+            </a:r>
+            <a:r>
+              <a:rPr b="0" sz="1300">
+                <a:solidFill>
+                  <a:srgbClr val="1E293B"/>
+                </a:solidFill>
+              </a:rPr>
+              <a:t> Substantially lowers emergency hospital visits through forward-looking smog warnings.</a:t>
+            </a:r>
+          </a:p>
+          <a:p>
+            <a:pPr>
               <a:spcAft>
-                <a:spcPts val="200"/>
+                <a:spcPts val="400"/>
               </a:spcAft>
             </a:pPr>
             <a:r>
-              <a:rPr sz="1100">
+              <a:rPr b="1" sz="1300">
                 <a:solidFill>
                   <a:srgbClr val="0F172A"/>
                 </a:solidFill>
               </a:rPr>
-              <a:t>- Social &amp; Health: Lowers emergency hospital visits and smog-related illnesses via proactive hourly warnings.</a:t>
-            </a:r>
-          </a:p>
-          <a:p>
-            <a:pPr lvl="1">
+              <a:t>• Economic:</a:t>
+            </a:r>
+            <a:r>
+              <a:rPr b="0" sz="1300">
+                <a:solidFill>
+                  <a:srgbClr val="1E293B"/>
+                </a:solidFill>
+              </a:rPr>
+              <a:t> Reduces healthcare expenditures and optimizes municipal pollution-mitigation budgets.</a:t>
+            </a:r>
+          </a:p>
+          <a:p>
+            <a:pPr>
               <a:spcAft>
-                <a:spcPts val="200"/>
+                <a:spcPts val="400"/>
               </a:spcAft>
             </a:pPr>
             <a:r>
-              <a:rPr sz="1100">
+              <a:rPr b="1" sz="1300">
                 <a:solidFill>
                   <a:srgbClr val="0F172A"/>
                 </a:solidFill>
               </a:rPr>
-              <a:t>- Economic: Reduces public healthcare expenditures; optimizes municipal smog-control operational budgets.</a:t>
-            </a:r>
-          </a:p>
-          <a:p>
-            <a:pPr lvl="1">
-              <a:spcAft>
-                <a:spcPts val="200"/>
-              </a:spcAft>
-            </a:pPr>
-            <a:r>
-              <a:rPr sz="1100">
-                <a:solidFill>
-                  <a:srgbClr val="0F172A"/>
-                </a:solidFill>
-              </a:rPr>
-              <a:t>- Environmental (Clean &amp; Green): Enhances public environmental consciousness and facilitates climate-informed urban planning.</a:t>
-            </a:r>
-          </a:p>
-          <a:p>
-            <a:pPr>
-              <a:spcBef>
-                <a:spcPts val="600"/>
-              </a:spcBef>
-              <a:spcAft>
-                <a:spcPts val="200"/>
-              </a:spcAft>
-            </a:pPr>
-            <a:r>
-              <a:rPr b="1" sz="1300">
-                <a:solidFill>
-                  <a:srgbClr val="105532"/>
-                </a:solidFill>
-              </a:rPr>
-              <a:t>3. Scalability &amp; Alignment with Clean &amp; Green Technology:</a:t>
-            </a:r>
-          </a:p>
-          <a:p>
-            <a:pPr lvl="1">
-              <a:spcAft>
-                <a:spcPts val="200"/>
-              </a:spcAft>
-            </a:pPr>
-            <a:r>
-              <a:rPr sz="1100">
-                <a:solidFill>
-                  <a:srgbClr val="0F172A"/>
-                </a:solidFill>
-              </a:rPr>
-              <a:t>- Directly aligns with National Clean Air Programme (NCAP) and UN Sustainable Development Goals (SDG 3 &amp; SDG 11).</a:t>
-            </a:r>
-          </a:p>
-          <a:p>
-            <a:pPr lvl="1">
-              <a:spcAft>
-                <a:spcPts val="200"/>
-              </a:spcAft>
-            </a:pPr>
-            <a:r>
-              <a:rPr sz="1100">
-                <a:solidFill>
-                  <a:srgbClr val="0F172A"/>
-                </a:solidFill>
-              </a:rPr>
-              <a:t>- Ready for sensor-network expansion: Can easily ingest municipal low-cost IoT sensor feeds and satellite remote sensing data.</a:t>
+              <a:t>• Environmental (Clean &amp; Green):</a:t>
+            </a:r>
+            <a:r>
+              <a:rPr b="0" sz="1300">
+                <a:solidFill>
+                  <a:srgbClr val="1E293B"/>
+                </a:solidFill>
+              </a:rPr>
+              <a:t> Aligns with National Clean Air Programme (NCAP) and UN SDGs (SDG 3: Good Health &amp; SDG 11: Sustainable Cities).</a:t>
             </a:r>
           </a:p>
         </p:txBody>
@@ -8067,8 +8132,8 @@
         </p:nvSpPr>
         <p:spPr>
           <a:xfrm>
-            <a:off x="329773" y="252246"/>
-            <a:ext cx="1251857" cy="807334"/>
+            <a:off x="612648" y="256032"/>
+            <a:ext cx="2148840" cy="594360"/>
           </a:xfrm>
           <a:prstGeom prst="ellipse">
             <a:avLst/>
@@ -8089,11 +8154,11 @@
           </a:fontRef>
         </p:style>
         <p:txBody>
-          <a:bodyPr rtlCol="0" anchor="ctr"/>
+          <a:bodyPr rtlCol="0" anchor="ctr" wrap="square"/>
           <a:lstStyle/>
           <a:p>
             <a:pPr algn="ctr">
-              <a:defRPr sz="1000" b="1">
+              <a:defRPr sz="1150" b="1">
                 <a:solidFill>
                   <a:srgbClr val="FFFFFF"/>
                 </a:solidFill>
@@ -8255,13 +8320,18 @@
             <p:ph type="title"/>
           </p:nvPr>
         </p:nvSpPr>
-        <p:spPr/>
-        <p:txBody>
-          <a:bodyPr/>
+        <p:spPr>
+          <a:xfrm>
+            <a:off x="2926080" y="201168"/>
+            <a:ext cx="6766560" cy="731520"/>
+          </a:xfrm>
+        </p:spPr>
+        <p:txBody>
+          <a:bodyPr wrap="square"/>
           <a:lstStyle/>
           <a:p>
-            <a:pPr eaLnBrk="1" hangingPunct="1">
-              <a:defRPr sz="2000" b="1">
+            <a:pPr eaLnBrk="1" hangingPunct="1" algn="l">
+              <a:defRPr sz="1700" b="1">
                 <a:solidFill>
                   <a:srgbClr val="105532"/>
                 </a:solidFill>
@@ -8283,8 +8353,8 @@
         </p:nvSpPr>
         <p:spPr bwMode="auto">
           <a:xfrm>
-            <a:off x="609600" y="2795263"/>
-            <a:ext cx="9385300" cy="523220"/>
+            <a:off x="612648" y="1143000"/>
+            <a:ext cx="10881360" cy="4983480"/>
           </a:xfrm>
           <a:prstGeom prst="rect">
             <a:avLst/>
@@ -8308,10 +8378,10 @@
                 <a:spcPct val="100000"/>
               </a:lnSpc>
               <a:spcBef>
-                <a:spcPts val="600"/>
+                <a:spcPts val="0"/>
               </a:spcBef>
               <a:spcAft>
-                <a:spcPts val="200"/>
+                <a:spcPts val="300"/>
               </a:spcAft>
               <a:buClrTx/>
               <a:buSzTx/>
@@ -8321,12 +8391,12 @@
               <a:defRPr/>
             </a:pPr>
             <a:r>
-              <a:rPr b="1" sz="1300">
+              <a:rPr b="1" sz="1550">
                 <a:solidFill>
                   <a:srgbClr val="105532"/>
                 </a:solidFill>
               </a:rPr>
-              <a:t>1. Scientific Standards &amp; Environmental Guidelines:</a:t>
+              <a:t>1. Environmental Standards &amp; Regulatory Frameworks:</a:t>
             </a:r>
             <a:endParaRPr kumimoji="0" lang="en-US" sz="2800" b="0" i="0" u="none" strike="noStrike" kern="1200" cap="none" spc="0" normalizeH="0" baseline="0" noProof="0" dirty="0">
               <a:ln>
@@ -8344,159 +8414,200 @@
             </a:endParaRPr>
           </a:p>
           <a:p>
-            <a:pPr lvl="1">
+            <a:pPr>
               <a:spcAft>
-                <a:spcPts val="200"/>
+                <a:spcPts val="400"/>
               </a:spcAft>
             </a:pPr>
             <a:r>
-              <a:rPr sz="1100">
+              <a:rPr b="1" sz="1300">
                 <a:solidFill>
                   <a:srgbClr val="0F172A"/>
                 </a:solidFill>
               </a:rPr>
-              <a:t>- US EPA (Environmental Protection Agency) Technical Assistance Document for the Reporting of Daily Air Quality (40 CFR Part 58).</a:t>
-            </a:r>
-          </a:p>
-          <a:p>
-            <a:pPr lvl="1">
+              <a:t>• US EPA Air Quality Index Standards:</a:t>
+            </a:r>
+            <a:r>
+              <a:rPr b="0" sz="1300">
+                <a:solidFill>
+                  <a:srgbClr val="1E293B"/>
+                </a:solidFill>
+              </a:rPr>
+              <a:t> Technical Assistance Document for Daily Air Quality Reporting (40 CFR Part 58).</a:t>
+            </a:r>
+          </a:p>
+          <a:p>
+            <a:pPr>
               <a:spcAft>
-                <a:spcPts val="200"/>
+                <a:spcPts val="400"/>
               </a:spcAft>
             </a:pPr>
             <a:r>
-              <a:rPr sz="1100">
+              <a:rPr b="1" sz="1300">
                 <a:solidFill>
                   <a:srgbClr val="0F172A"/>
                 </a:solidFill>
               </a:rPr>
-              <a:t>- World Health Organization (WHO) Global Air Quality Guidelines (2021) - Target thresholds for PM2.5, PM10, O3, NO2, SO2, CO.</a:t>
-            </a:r>
-          </a:p>
-          <a:p>
-            <a:pPr lvl="1">
+              <a:t>• World Health Organization (WHO):</a:t>
+            </a:r>
+            <a:r>
+              <a:rPr b="0" sz="1300">
+                <a:solidFill>
+                  <a:srgbClr val="1E293B"/>
+                </a:solidFill>
+              </a:rPr>
+              <a:t> Global Air Quality Guidelines (2021) — Health thresholds for PM2.5, PM10, O3, NO2, SO2, CO.</a:t>
+            </a:r>
+          </a:p>
+          <a:p>
+            <a:pPr>
               <a:spcAft>
-                <a:spcPts val="200"/>
+                <a:spcPts val="400"/>
               </a:spcAft>
             </a:pPr>
             <a:r>
-              <a:rPr sz="1100">
+              <a:rPr b="1" sz="1300">
                 <a:solidFill>
                   <a:srgbClr val="0F172A"/>
                 </a:solidFill>
               </a:rPr>
-              <a:t>- Central Pollution Control Board (CPCB) India - National Air Quality Index (NAQI) Methodologies and Breakpoints.</a:t>
+              <a:t>• Central Pollution Control Board (CPCB):</a:t>
+            </a:r>
+            <a:r>
+              <a:rPr b="0" sz="1300">
+                <a:solidFill>
+                  <a:srgbClr val="1E293B"/>
+                </a:solidFill>
+              </a:rPr>
+              <a:t> National Air Quality Index (NAQI) breakpoints and category scales.</a:t>
             </a:r>
           </a:p>
           <a:p>
             <a:pPr>
               <a:spcBef>
-                <a:spcPts val="600"/>
+                <a:spcPts val="800"/>
               </a:spcBef>
               <a:spcAft>
-                <a:spcPts val="200"/>
+                <a:spcPts val="300"/>
               </a:spcAft>
             </a:pPr>
             <a:r>
+              <a:rPr b="1" sz="1550">
+                <a:solidFill>
+                  <a:srgbClr val="105532"/>
+                </a:solidFill>
+              </a:rPr>
+              <a:t>2. Meteorological &amp; Atmospheric Research:</a:t>
+            </a:r>
+          </a:p>
+          <a:p>
+            <a:pPr>
+              <a:spcAft>
+                <a:spcPts val="400"/>
+              </a:spcAft>
+            </a:pPr>
+            <a:r>
               <a:rPr b="1" sz="1300">
                 <a:solidFill>
-                  <a:srgbClr val="105532"/>
-                </a:solidFill>
-              </a:rPr>
-              <a:t>2. Meteorological &amp; Atmospheric Dispersion Research:</a:t>
-            </a:r>
-          </a:p>
-          <a:p>
-            <a:pPr lvl="1">
+                  <a:srgbClr val="0F172A"/>
+                </a:solidFill>
+              </a:rPr>
+              <a:t>• Boundary Layer Meteorology:</a:t>
+            </a:r>
+            <a:r>
+              <a:rPr b="0" sz="1300">
+                <a:solidFill>
+                  <a:srgbClr val="1E293B"/>
+                </a:solidFill>
+              </a:rPr>
+              <a:t> Stull, R. B. (1988) — Planetary Boundary Layer dynamics and thermal inversion mechanics.</a:t>
+            </a:r>
+          </a:p>
+          <a:p>
+            <a:pPr>
               <a:spcAft>
-                <a:spcPts val="200"/>
+                <a:spcPts val="400"/>
               </a:spcAft>
             </a:pPr>
             <a:r>
-              <a:rPr sz="1100">
+              <a:rPr b="1" sz="1300">
                 <a:solidFill>
                   <a:srgbClr val="0F172A"/>
                 </a:solidFill>
               </a:rPr>
-              <a:t>- Stull, R. B. (1988). An Introduction to Boundary Layer Meteorology. Kluwer Academic Publishers - Thermal Inversions and PBL Dynamics.</a:t>
-            </a:r>
-          </a:p>
-          <a:p>
-            <a:pPr lvl="1">
-              <a:spcAft>
-                <a:spcPts val="200"/>
-              </a:spcAft>
-            </a:pPr>
-            <a:r>
-              <a:rPr sz="1100">
-                <a:solidFill>
-                  <a:srgbClr val="0F172A"/>
-                </a:solidFill>
-              </a:rPr>
-              <a:t>- Seinfeld, J. H., &amp; Pandis, S. N. (2016). Atmospheric Chemistry and Physics: From Air Pollution to Climate Change (3rd Edition).</a:t>
-            </a:r>
-          </a:p>
-          <a:p>
-            <a:pPr lvl="1">
-              <a:spcAft>
-                <a:spcPts val="200"/>
-              </a:spcAft>
-            </a:pPr>
-            <a:r>
-              <a:rPr sz="1100">
-                <a:solidFill>
-                  <a:srgbClr val="0F172A"/>
-                </a:solidFill>
-              </a:rPr>
-              <a:t>- Open-Meteo Documentation &amp; Reanalysis Models (ERA5, CAMS - Copernicus Atmosphere Monitoring Service).</a:t>
+              <a:t>• Atmospheric Chemistry &amp; Physics:</a:t>
+            </a:r>
+            <a:r>
+              <a:rPr b="0" sz="1300">
+                <a:solidFill>
+                  <a:srgbClr val="1E293B"/>
+                </a:solidFill>
+              </a:rPr>
+              <a:t> Seinfeld, J. H., &amp; Pandis, S. N. (2016) — Wet deposition, aerosol growth, and photochemical smog.</a:t>
             </a:r>
           </a:p>
           <a:p>
             <a:pPr>
               <a:spcBef>
-                <a:spcPts val="600"/>
+                <a:spcPts val="800"/>
               </a:spcBef>
               <a:spcAft>
-                <a:spcPts val="200"/>
+                <a:spcPts val="300"/>
               </a:spcAft>
             </a:pPr>
             <a:r>
+              <a:rPr b="1" sz="1550">
+                <a:solidFill>
+                  <a:srgbClr val="105532"/>
+                </a:solidFill>
+              </a:rPr>
+              <a:t>3. Project Repository &amp; Working Prototype:</a:t>
+            </a:r>
+          </a:p>
+          <a:p>
+            <a:pPr>
+              <a:spcAft>
+                <a:spcPts val="400"/>
+              </a:spcAft>
+            </a:pPr>
+            <a:r>
               <a:rPr b="1" sz="1300">
                 <a:solidFill>
-                  <a:srgbClr val="105532"/>
-                </a:solidFill>
-              </a:rPr>
-              <a:t>3. Project Repository &amp; Live Prototype:</a:t>
-            </a:r>
-          </a:p>
-          <a:p>
-            <a:pPr lvl="1">
+                  <a:srgbClr val="0F172A"/>
+                </a:solidFill>
+              </a:rPr>
+              <a:t>• GitHub Repository:</a:t>
+            </a:r>
+            <a:r>
+              <a:rPr b="0" sz="1300">
+                <a:solidFill>
+                  <a:srgbClr val="1E293B"/>
+                </a:solidFill>
+              </a:rPr>
+              <a:t> https://github.com/NirmalSushil/SIH26082.git</a:t>
+            </a:r>
+          </a:p>
+          <a:p>
+            <a:pPr>
               <a:spcAft>
-                <a:spcPts val="200"/>
+                <a:spcPts val="400"/>
               </a:spcAft>
             </a:pPr>
             <a:r>
-              <a:rPr sz="1100">
+              <a:rPr b="1" sz="1300">
                 <a:solidFill>
                   <a:srgbClr val="0F172A"/>
                 </a:solidFill>
               </a:rPr>
-              <a:t>- GitHub Repository: https://github.com/NirmalSushil/SIH26082.git</a:t>
-            </a:r>
-          </a:p>
-          <a:p>
-            <a:pPr lvl="1">
-              <a:spcAft>
-                <a:spcPts val="200"/>
-              </a:spcAft>
-            </a:pPr>
-            <a:r>
-              <a:rPr sz="1100">
-                <a:solidFill>
-                  <a:srgbClr val="0F172A"/>
-                </a:solidFill>
-              </a:rPr>
-              <a:t>- Live Prototype: Next.js 16 Coupled Forecast Dashboard with default Mumbai, Favorites/Bookmarks, and Light/Dark Modes.</a:t>
+              <a:t>• Live Prototype:</a:t>
+            </a:r>
+            <a:r>
+              <a:rPr b="0" sz="1300">
+                <a:solidFill>
+                  <a:srgbClr val="1E293B"/>
+                </a:solidFill>
+              </a:rPr>
+              <a:t> Next.js 16 Coupled Forecast Dashboard with default Mumbai, Favorites/Bookmarks, and Light/Dark Modes.</a:t>
             </a:r>
           </a:p>
         </p:txBody>
@@ -8672,8 +8783,8 @@
         </p:nvSpPr>
         <p:spPr>
           <a:xfrm>
-            <a:off x="329773" y="252246"/>
-            <a:ext cx="1251857" cy="807334"/>
+            <a:off x="612648" y="256032"/>
+            <a:ext cx="2148840" cy="594360"/>
           </a:xfrm>
           <a:prstGeom prst="ellipse">
             <a:avLst/>
@@ -8694,11 +8805,11 @@
           </a:fontRef>
         </p:style>
         <p:txBody>
-          <a:bodyPr rtlCol="0" anchor="ctr"/>
+          <a:bodyPr rtlCol="0" anchor="ctr" wrap="square"/>
           <a:lstStyle/>
           <a:p>
             <a:pPr algn="ctr">
-              <a:defRPr sz="1000" b="1">
+              <a:defRPr sz="1150" b="1">
                 <a:solidFill>
                   <a:srgbClr val="FFFFFF"/>
                 </a:solidFill>

</xml_diff>